<commit_message>
Rebuild Lecture-4 with charts and visual layouts
5 embedded images: decision tree flowchart, Gini impurity pie charts,
attack signature cards, feature importance bars, overfitting depth chart.
Uses 2-Column, Bullets+Pull Quote, and Title Only layouts.
</commit_message>
<xml_diff>
--- a/stage1_classic_ml/04_decision_trees/Lecture-4-Decision-Trees.pptx
+++ b/stage1_classic_ml/04_decision_trees/Lecture-4-Decision-Trees.pptx
@@ -27,6 +27,8 @@
     <p:sldId id="269" r:id="rId25"/>
     <p:sldId id="270" r:id="rId26"/>
     <p:sldId id="271" r:id="rId27"/>
+    <p:sldId id="272" r:id="rId28"/>
+    <p:sldId id="273" r:id="rId29"/>
   </p:sldIdLst>
   <p:sldSz cx="12188825" cy="6858000"/>
   <p:notesSz cx="7010400" cy="9296400"/>
@@ -8397,12 +8399,12 @@
       <p:grpSpPr/>
       <p:sp>
         <p:nvSpPr>
-          <p:cNvPr id="2" name="Text Placeholder 1"/>
+          <p:cNvPr id="2" name="Title 1"/>
           <p:cNvSpPr>
             <a:spLocks noGrp="1"/>
           </p:cNvSpPr>
           <p:nvPr>
-            <p:ph type="body" idx="13" sz="quarter"/>
+            <p:ph type="title"/>
           </p:nvPr>
         </p:nvSpPr>
         <p:spPr/>
@@ -8411,37 +8413,35 @@
           <a:lstStyle/>
           <a:p>
             <a:r>
-              <a:t>Overfitting &amp;</a:t>
-            </a:r>
-          </a:p>
-          <a:p>
-            <a:r>
-              <a:t>Tree Depth</a:t>
-            </a:r>
-          </a:p>
-        </p:txBody>
-      </p:sp>
-      <p:sp>
-        <p:nvSpPr>
-          <p:cNvPr id="3" name="Text Placeholder 2"/>
-          <p:cNvSpPr>
-            <a:spLocks noGrp="1"/>
-          </p:cNvSpPr>
-          <p:nvPr>
-            <p:ph type="body" idx="16" sz="quarter"/>
-          </p:nvPr>
-        </p:nvSpPr>
-        <p:spPr/>
-        <p:txBody>
-          <a:bodyPr/>
-          <a:lstStyle/>
-          <a:p>
-            <a:r>
-              <a:t>04</a:t>
-            </a:r>
-          </a:p>
-        </p:txBody>
-      </p:sp>
+              <a:t>Attack Signatures in Network Features</a:t>
+            </a:r>
+          </a:p>
+        </p:txBody>
+      </p:sp>
+      <p:pic>
+        <p:nvPicPr>
+          <p:cNvPr id="3" name="Picture 2" descr="dt_attacks.png"/>
+          <p:cNvPicPr>
+            <a:picLocks noChangeAspect="1"/>
+          </p:cNvPicPr>
+          <p:nvPr/>
+        </p:nvPicPr>
+        <p:blipFill>
+          <a:blip r:embed="rId2"/>
+          <a:stretch>
+            <a:fillRect/>
+          </a:stretch>
+        </p:blipFill>
+        <p:spPr>
+          <a:xfrm>
+            <a:off x="274320" y="1371600"/>
+            <a:ext cx="11430000" cy="4159541"/>
+          </a:xfrm>
+          <a:prstGeom prst="rect">
+            <a:avLst/>
+          </a:prstGeom>
+        </p:spPr>
+      </p:pic>
     </p:spTree>
   </p:cSld>
   <p:clrMapOvr>
@@ -8476,75 +8476,35 @@
           <a:lstStyle/>
           <a:p>
             <a:r>
-              <a:t>Overfitting — The Tree's Weakness</a:t>
-            </a:r>
-          </a:p>
-        </p:txBody>
-      </p:sp>
-      <p:sp>
-        <p:nvSpPr>
-          <p:cNvPr id="3" name="Content Placeholder 2"/>
-          <p:cNvSpPr>
-            <a:spLocks noGrp="1"/>
-          </p:cNvSpPr>
-          <p:nvPr>
-            <p:ph idx="1"/>
-          </p:nvPr>
-        </p:nvSpPr>
-        <p:spPr/>
-        <p:txBody>
-          <a:bodyPr/>
-          <a:lstStyle/>
-          <a:p>
-            <a:pPr/>
-            <a:r>
-              <a:t>An unconstrained tree memorises the training data perfectly</a:t>
-            </a:r>
-          </a:p>
-          <a:p>
-            <a:pPr lvl="1"/>
-            <a:r>
-              <a:t>It creates a rule for every edge case — perfect training accuracy</a:t>
-            </a:r>
-          </a:p>
-          <a:p>
-            <a:pPr lvl="1"/>
-            <a:r>
-              <a:t>But fails on new data — poor test accuracy</a:t>
-            </a:r>
-          </a:p>
-          <a:p>
-            <a:pPr/>
-            <a:r>
-              <a:t>Control overfitting with hyperparameters:</a:t>
-            </a:r>
-          </a:p>
-          <a:p>
-            <a:pPr lvl="1"/>
-            <a:r>
-              <a:t>max_depth — limits how deep the tree grows</a:t>
-            </a:r>
-          </a:p>
-          <a:p>
-            <a:pPr lvl="1"/>
-            <a:r>
-              <a:t>min_samples_split — minimum samples needed to create a new split</a:t>
-            </a:r>
-          </a:p>
-          <a:p>
-            <a:pPr/>
-            <a:r>
-              <a:t>Finding the right max_depth is the key tuning task</a:t>
-            </a:r>
-          </a:p>
-          <a:p>
-            <a:pPr/>
-            <a:r>
-              <a:t>Too shallow → underfitting. Too deep → overfitting.</a:t>
-            </a:r>
-          </a:p>
-        </p:txBody>
-      </p:sp>
+              <a:t>Feature Importance — Which Network Features Matter Most?</a:t>
+            </a:r>
+          </a:p>
+        </p:txBody>
+      </p:sp>
+      <p:pic>
+        <p:nvPicPr>
+          <p:cNvPr id="3" name="Picture 2" descr="dt_importance.png"/>
+          <p:cNvPicPr>
+            <a:picLocks noChangeAspect="1"/>
+          </p:cNvPicPr>
+          <p:nvPr/>
+        </p:nvPicPr>
+        <p:blipFill>
+          <a:blip r:embed="rId2"/>
+          <a:stretch>
+            <a:fillRect/>
+          </a:stretch>
+        </p:blipFill>
+        <p:spPr>
+          <a:xfrm>
+            <a:off x="2011680" y="1371600"/>
+            <a:ext cx="8229600" cy="4507893"/>
+          </a:xfrm>
+          <a:prstGeom prst="rect">
+            <a:avLst/>
+          </a:prstGeom>
+        </p:spPr>
+      </p:pic>
     </p:spTree>
   </p:cSld>
   <p:clrMapOvr>
@@ -8565,12 +8525,12 @@
       <p:grpSpPr/>
       <p:sp>
         <p:nvSpPr>
-          <p:cNvPr id="2" name="Title 1"/>
+          <p:cNvPr id="2" name="Text Placeholder 1"/>
           <p:cNvSpPr>
             <a:spLocks noGrp="1"/>
           </p:cNvSpPr>
           <p:nvPr>
-            <p:ph type="title"/>
+            <p:ph type="body" idx="13" sz="quarter"/>
           </p:nvPr>
         </p:nvSpPr>
         <p:spPr/>
@@ -8579,19 +8539,24 @@
           <a:lstStyle/>
           <a:p>
             <a:r>
-              <a:t>Why Decision Trees Matter in Security</a:t>
-            </a:r>
-          </a:p>
-        </p:txBody>
-      </p:sp>
-      <p:sp>
-        <p:nvSpPr>
-          <p:cNvPr id="3" name="Content Placeholder 2"/>
+              <a:t>Overfitting &amp;</a:t>
+            </a:r>
+          </a:p>
+          <a:p>
+            <a:r>
+              <a:t>Tree Depth</a:t>
+            </a:r>
+          </a:p>
+        </p:txBody>
+      </p:sp>
+      <p:sp>
+        <p:nvSpPr>
+          <p:cNvPr id="3" name="Text Placeholder 2"/>
           <p:cNvSpPr>
             <a:spLocks noGrp="1"/>
           </p:cNvSpPr>
           <p:nvPr>
-            <p:ph idx="1"/>
+            <p:ph type="body" idx="16" sz="quarter"/>
           </p:nvPr>
         </p:nvSpPr>
         <p:spPr/>
@@ -8599,45 +8564,8 @@
           <a:bodyPr/>
           <a:lstStyle/>
           <a:p>
-            <a:pPr/>
-            <a:r>
-              <a:t>1. Interpretable — you can explain exactly why a connection was flagged</a:t>
-            </a:r>
-          </a:p>
-          <a:p>
-            <a:pPr/>
-            <a:r>
-              <a:t>2. No feature scaling needed — unlike logistic regression</a:t>
-            </a:r>
-          </a:p>
-          <a:p>
-            <a:pPr/>
-            <a:r>
-              <a:t>3. Handles non-linear patterns — complex threshold combinations</a:t>
-            </a:r>
-          </a:p>
-          <a:p>
-            <a:pPr/>
-            <a:r>
-              <a:t>4. Basis for Random Forests (Stage 2) — ensemble of many trees</a:t>
-            </a:r>
-          </a:p>
-          <a:p>
-            <a:pPr/>
-            <a:r>
-              <a:t>5. Can visualise the entire model:</a:t>
-            </a:r>
-          </a:p>
-          <a:p>
-            <a:pPr lvl="1"/>
-            <a:r>
-              <a:t>plot_tree(model, feature_names=..., class_names=..., filled=True)</a:t>
-            </a:r>
-          </a:p>
-          <a:p>
-            <a:pPr lvl="1"/>
-            <a:r>
-              <a:t>The result is a readable flowchart of learned rules</a:t>
+            <a:r>
+              <a:t>04</a:t>
             </a:r>
           </a:p>
         </p:txBody>
@@ -8662,12 +8590,12 @@
       <p:grpSpPr/>
       <p:sp>
         <p:nvSpPr>
-          <p:cNvPr id="2" name="Text Placeholder 1"/>
+          <p:cNvPr id="2" name="Title 1"/>
           <p:cNvSpPr>
             <a:spLocks noGrp="1"/>
           </p:cNvSpPr>
           <p:nvPr>
-            <p:ph type="body" idx="13" sz="quarter"/>
+            <p:ph type="title"/>
           </p:nvPr>
         </p:nvSpPr>
         <p:spPr/>
@@ -8676,32 +8604,35 @@
           <a:lstStyle/>
           <a:p>
             <a:r>
-              <a:t>Workshop</a:t>
-            </a:r>
-          </a:p>
-        </p:txBody>
-      </p:sp>
-      <p:sp>
-        <p:nvSpPr>
-          <p:cNvPr id="3" name="Text Placeholder 2"/>
-          <p:cNvSpPr>
-            <a:spLocks noGrp="1"/>
-          </p:cNvSpPr>
-          <p:nvPr>
-            <p:ph type="body" idx="16" sz="quarter"/>
-          </p:nvPr>
-        </p:nvSpPr>
-        <p:spPr/>
-        <p:txBody>
-          <a:bodyPr/>
-          <a:lstStyle/>
-          <a:p>
-            <a:r>
-              <a:t>05</a:t>
-            </a:r>
-          </a:p>
-        </p:txBody>
-      </p:sp>
+              <a:t>Overfitting — Train vs Test Accuracy at Different Depths</a:t>
+            </a:r>
+          </a:p>
+        </p:txBody>
+      </p:sp>
+      <p:pic>
+        <p:nvPicPr>
+          <p:cNvPr id="3" name="Picture 2" descr="dt_overfitting.png"/>
+          <p:cNvPicPr>
+            <a:picLocks noChangeAspect="1"/>
+          </p:cNvPicPr>
+          <p:nvPr/>
+        </p:nvPicPr>
+        <p:blipFill>
+          <a:blip r:embed="rId2"/>
+          <a:stretch>
+            <a:fillRect/>
+          </a:stretch>
+        </p:blipFill>
+        <p:spPr>
+          <a:xfrm>
+            <a:off x="2011680" y="1371600"/>
+            <a:ext cx="8229600" cy="4992530"/>
+          </a:xfrm>
+          <a:prstGeom prst="rect">
+            <a:avLst/>
+          </a:prstGeom>
+        </p:spPr>
+      </p:pic>
     </p:spTree>
   </p:cSld>
   <p:clrMapOvr>
@@ -8736,7 +8667,7 @@
           <a:lstStyle/>
           <a:p>
             <a:r>
-              <a:t>Workshop — 4 Exercises</a:t>
+              <a:t>Controlling Overfitting</a:t>
             </a:r>
           </a:p>
         </p:txBody>
@@ -8748,7 +8679,7 @@
             <a:spLocks noGrp="1"/>
           </p:cNvSpPr>
           <p:nvPr>
-            <p:ph idx="1"/>
+            <p:ph idx="2" sz="half"/>
           </p:nvPr>
         </p:nvSpPr>
         <p:spPr/>
@@ -8758,49 +8689,98 @@
           <a:p>
             <a:pPr/>
             <a:r>
-              <a:t>Exercise 1: How trees make decisions — Gini impurity, information gain</a:t>
+              <a:t>Too Deep (overfitting)</a:t>
             </a:r>
           </a:p>
           <a:p>
             <a:pPr/>
-            <a:r>
-              <a:t>Exercise 2: Train and read the tree — plot_tree(), interpret learned rules</a:t>
-            </a:r>
           </a:p>
           <a:p>
             <a:pPr/>
             <a:r>
-              <a:t>Exercise 3: Feature importance — which network features matter most</a:t>
+              <a:t>Memorises training data perfectly</a:t>
             </a:r>
           </a:p>
           <a:p>
             <a:pPr/>
             <a:r>
-              <a:t>Exercise 4: Depth and overfitting — max_depth sweep, train vs test accuracy</a:t>
+              <a:t>Creates a rule for every edge case</a:t>
             </a:r>
           </a:p>
           <a:p>
             <a:pPr/>
             <a:r>
-              <a:t>Each exercise has:</a:t>
-            </a:r>
-          </a:p>
-          <a:p>
-            <a:pPr lvl="1"/>
-            <a:r>
-              <a:t>lecture.md — concept explanation</a:t>
-            </a:r>
-          </a:p>
-          <a:p>
-            <a:pPr lvl="1"/>
-            <a:r>
-              <a:t>handson.md — step-by-step lab</a:t>
-            </a:r>
-          </a:p>
-          <a:p>
-            <a:pPr lvl="1"/>
-            <a:r>
-              <a:t>solution_decision_trees.py — reference implementation</a:t>
+              <a:t>Perfect training accuracy</a:t>
+            </a:r>
+          </a:p>
+          <a:p>
+            <a:pPr/>
+            <a:r>
+              <a:t>Poor test accuracy</a:t>
+            </a:r>
+          </a:p>
+          <a:p>
+            <a:pPr/>
+            <a:r>
+              <a:t>The gap widens with depth</a:t>
+            </a:r>
+          </a:p>
+        </p:txBody>
+      </p:sp>
+      <p:sp>
+        <p:nvSpPr>
+          <p:cNvPr id="4" name="Content Placeholder 3"/>
+          <p:cNvSpPr>
+            <a:spLocks noGrp="1"/>
+          </p:cNvSpPr>
+          <p:nvPr>
+            <p:ph idx="12" sz="half"/>
+          </p:nvPr>
+        </p:nvSpPr>
+        <p:spPr/>
+        <p:txBody>
+          <a:bodyPr/>
+          <a:lstStyle/>
+          <a:p>
+            <a:pPr/>
+            <a:r>
+              <a:t>Controls</a:t>
+            </a:r>
+          </a:p>
+          <a:p>
+            <a:pPr/>
+          </a:p>
+          <a:p>
+            <a:pPr/>
+            <a:r>
+              <a:t>max_depth — limits tree growth</a:t>
+            </a:r>
+          </a:p>
+          <a:p>
+            <a:pPr/>
+            <a:r>
+              <a:t>min_samples_split — minimum samples to split</a:t>
+            </a:r>
+          </a:p>
+          <a:p>
+            <a:pPr/>
+          </a:p>
+          <a:p>
+            <a:pPr/>
+            <a:r>
+              <a:t>Finding the sweet spot is the key task</a:t>
+            </a:r>
+          </a:p>
+          <a:p>
+            <a:pPr/>
+            <a:r>
+              <a:t>Too shallow = underfitting</a:t>
+            </a:r>
+          </a:p>
+          <a:p>
+            <a:pPr/>
+            <a:r>
+              <a:t>Too deep = overfitting</a:t>
             </a:r>
           </a:p>
         </p:txBody>
@@ -8830,7 +8810,7 @@
             <a:spLocks noGrp="1"/>
           </p:cNvSpPr>
           <p:nvPr>
-            <p:ph type="body" idx="12" sz="quarter"/>
+            <p:ph type="body" idx="13" sz="quarter"/>
           </p:nvPr>
         </p:nvSpPr>
         <p:spPr/>
@@ -8838,57 +8818,20 @@
           <a:bodyPr/>
           <a:lstStyle/>
           <a:p>
-            <a:pPr/>
-            <a:r>
-              <a:t>Decision trees learn if/else rules from data — no hand-crafting needed</a:t>
-            </a:r>
-          </a:p>
-          <a:p>
-            <a:pPr/>
-            <a:r>
-              <a:t>Splits are chosen by Gini impurity to maximise class separation</a:t>
-            </a:r>
-          </a:p>
-          <a:p>
-            <a:pPr/>
-            <a:r>
-              <a:t>feature_importances_ reveals which inputs drive the model's decisions</a:t>
-            </a:r>
-          </a:p>
-          <a:p>
-            <a:pPr/>
-            <a:r>
-              <a:t>max_depth controls the overfitting/underfitting tradeoff</a:t>
-            </a:r>
-          </a:p>
-          <a:p>
-            <a:pPr/>
-            <a:r>
-              <a:t>Trees are interpretable, need no scaling, and handle non-linear patterns</a:t>
-            </a:r>
-          </a:p>
-          <a:p>
-            <a:pPr/>
-            <a:r>
-              <a:t>They are the building block for Random Forests in Stage 2</a:t>
-            </a:r>
-          </a:p>
-          <a:p>
-            <a:pPr/>
-            <a:r>
-              <a:t>Next: Lesson 1.5 — Model Evaluation</a:t>
-            </a:r>
-          </a:p>
-        </p:txBody>
-      </p:sp>
-      <p:sp>
-        <p:nvSpPr>
-          <p:cNvPr id="3" name="Title 2"/>
+            <a:r>
+              <a:t>Workshop</a:t>
+            </a:r>
+          </a:p>
+        </p:txBody>
+      </p:sp>
+      <p:sp>
+        <p:nvSpPr>
+          <p:cNvPr id="3" name="Text Placeholder 2"/>
           <p:cNvSpPr>
             <a:spLocks noGrp="1"/>
           </p:cNvSpPr>
           <p:nvPr>
-            <p:ph type="title"/>
+            <p:ph type="body" idx="16" sz="quarter"/>
           </p:nvPr>
         </p:nvSpPr>
         <p:spPr/>
@@ -8897,7 +8840,7 @@
           <a:lstStyle/>
           <a:p>
             <a:r>
-              <a:t>Summary</a:t>
+              <a:t>05</a:t>
             </a:r>
           </a:p>
         </p:txBody>
@@ -8922,6 +8865,191 @@
       <p:grpSpPr/>
       <p:sp>
         <p:nvSpPr>
+          <p:cNvPr id="2" name="Title 1"/>
+          <p:cNvSpPr>
+            <a:spLocks noGrp="1"/>
+          </p:cNvSpPr>
+          <p:nvPr>
+            <p:ph type="title"/>
+          </p:nvPr>
+        </p:nvSpPr>
+        <p:spPr/>
+        <p:txBody>
+          <a:bodyPr/>
+          <a:lstStyle/>
+          <a:p>
+            <a:r>
+              <a:t>Workshop — 4 Exercises</a:t>
+            </a:r>
+          </a:p>
+        </p:txBody>
+      </p:sp>
+      <p:sp>
+        <p:nvSpPr>
+          <p:cNvPr id="3" name="Content Placeholder 2"/>
+          <p:cNvSpPr>
+            <a:spLocks noGrp="1"/>
+          </p:cNvSpPr>
+          <p:nvPr>
+            <p:ph idx="1"/>
+          </p:nvPr>
+        </p:nvSpPr>
+        <p:spPr/>
+        <p:txBody>
+          <a:bodyPr/>
+          <a:lstStyle/>
+          <a:p>
+            <a:pPr/>
+            <a:r>
+              <a:t>Exercise 1: How trees make decisions — Gini impurity, information gain</a:t>
+            </a:r>
+          </a:p>
+          <a:p>
+            <a:pPr/>
+            <a:r>
+              <a:t>Exercise 2: Train and read the tree — plot_tree(), interpret learned rules</a:t>
+            </a:r>
+          </a:p>
+          <a:p>
+            <a:pPr/>
+            <a:r>
+              <a:t>Exercise 3: Feature importance — which network features matter most</a:t>
+            </a:r>
+          </a:p>
+          <a:p>
+            <a:pPr/>
+            <a:r>
+              <a:t>Exercise 4: Depth and overfitting — max_depth sweep, train vs test accuracy</a:t>
+            </a:r>
+          </a:p>
+          <a:p>
+            <a:pPr/>
+          </a:p>
+          <a:p>
+            <a:pPr/>
+            <a:r>
+              <a:t>Each exercise: lecture.md → handson.md → solution_decision_trees.py</a:t>
+            </a:r>
+          </a:p>
+        </p:txBody>
+      </p:sp>
+    </p:spTree>
+  </p:cSld>
+  <p:clrMapOvr>
+    <a:masterClrMapping/>
+  </p:clrMapOvr>
+</p:sld>
+</file>
+
+<file path=ppt/slides/slide17.xml><?xml version="1.0" encoding="utf-8"?>
+<p:sld xmlns:a="http://schemas.openxmlformats.org/drawingml/2006/main" xmlns:p="http://schemas.openxmlformats.org/presentationml/2006/main" xmlns:r="http://schemas.openxmlformats.org/officeDocument/2006/relationships">
+  <p:cSld>
+    <p:spTree>
+      <p:nvGrpSpPr>
+        <p:cNvPr id="1" name=""/>
+        <p:cNvGrpSpPr/>
+        <p:nvPr/>
+      </p:nvGrpSpPr>
+      <p:grpSpPr/>
+      <p:sp>
+        <p:nvSpPr>
+          <p:cNvPr id="2" name="Text Placeholder 1"/>
+          <p:cNvSpPr>
+            <a:spLocks noGrp="1"/>
+          </p:cNvSpPr>
+          <p:nvPr>
+            <p:ph type="body" idx="12" sz="quarter"/>
+          </p:nvPr>
+        </p:nvSpPr>
+        <p:spPr/>
+        <p:txBody>
+          <a:bodyPr/>
+          <a:lstStyle/>
+          <a:p>
+            <a:pPr/>
+            <a:r>
+              <a:t>Decision trees learn if/else rules from data — no hand-crafting needed</a:t>
+            </a:r>
+          </a:p>
+          <a:p>
+            <a:pPr/>
+            <a:r>
+              <a:t>Splits are chosen by Gini impurity to maximise class separation</a:t>
+            </a:r>
+          </a:p>
+          <a:p>
+            <a:pPr/>
+            <a:r>
+              <a:t>feature_importances_ reveals which inputs drive the model's decisions</a:t>
+            </a:r>
+          </a:p>
+          <a:p>
+            <a:pPr/>
+            <a:r>
+              <a:t>max_depth controls the overfitting/underfitting tradeoff</a:t>
+            </a:r>
+          </a:p>
+          <a:p>
+            <a:pPr/>
+            <a:r>
+              <a:t>Trees are interpretable, need no scaling, and handle non-linear patterns</a:t>
+            </a:r>
+          </a:p>
+          <a:p>
+            <a:pPr/>
+            <a:r>
+              <a:t>They are the building block for Random Forests in Stage 2</a:t>
+            </a:r>
+          </a:p>
+          <a:p>
+            <a:pPr/>
+            <a:r>
+              <a:t>Next: Lesson 1.5 — Model Evaluation</a:t>
+            </a:r>
+          </a:p>
+        </p:txBody>
+      </p:sp>
+      <p:sp>
+        <p:nvSpPr>
+          <p:cNvPr id="3" name="Title 2"/>
+          <p:cNvSpPr>
+            <a:spLocks noGrp="1"/>
+          </p:cNvSpPr>
+          <p:nvPr>
+            <p:ph type="title"/>
+          </p:nvPr>
+        </p:nvSpPr>
+        <p:spPr/>
+        <p:txBody>
+          <a:bodyPr/>
+          <a:lstStyle/>
+          <a:p>
+            <a:r>
+              <a:t>Summary</a:t>
+            </a:r>
+          </a:p>
+        </p:txBody>
+      </p:sp>
+    </p:spTree>
+  </p:cSld>
+  <p:clrMapOvr>
+    <a:masterClrMapping/>
+  </p:clrMapOvr>
+</p:sld>
+</file>
+
+<file path=ppt/slides/slide18.xml><?xml version="1.0" encoding="utf-8"?>
+<p:sld xmlns:a="http://schemas.openxmlformats.org/drawingml/2006/main" xmlns:p="http://schemas.openxmlformats.org/presentationml/2006/main" xmlns:r="http://schemas.openxmlformats.org/officeDocument/2006/relationships">
+  <p:cSld>
+    <p:spTree>
+      <p:nvGrpSpPr>
+        <p:cNvPr id="1" name=""/>
+        <p:cNvGrpSpPr/>
+        <p:nvPr/>
+      </p:nvGrpSpPr>
+      <p:grpSpPr/>
+      <p:sp>
+        <p:nvSpPr>
           <p:cNvPr id="2" name="Text Placeholder 1"/>
           <p:cNvSpPr>
             <a:spLocks noGrp="1"/>
@@ -9003,13 +9131,13 @@
           <a:p>
             <a:pPr/>
             <a:r>
-              <a:t>Real-life example: network traffic classifier</a:t>
+              <a:t>How splits are chosen — Gini impurity</a:t>
             </a:r>
           </a:p>
           <a:p>
             <a:pPr/>
             <a:r>
-              <a:t>How splits are chosen — Gini impurity</a:t>
+              <a:t>Real-life: network traffic classifier</a:t>
             </a:r>
           </a:p>
           <a:p>
@@ -9158,69 +9286,35 @@
           <a:lstStyle/>
           <a:p>
             <a:r>
-              <a:t>Decision Trees — A Flowchart of Yes/No Questions</a:t>
-            </a:r>
-          </a:p>
-        </p:txBody>
-      </p:sp>
-      <p:sp>
-        <p:nvSpPr>
-          <p:cNvPr id="3" name="Content Placeholder 2"/>
-          <p:cNvSpPr>
-            <a:spLocks noGrp="1"/>
-          </p:cNvSpPr>
-          <p:nvPr>
-            <p:ph idx="1"/>
-          </p:nvPr>
-        </p:nvSpPr>
-        <p:spPr/>
-        <p:txBody>
-          <a:bodyPr/>
-          <a:lstStyle/>
-          <a:p>
-            <a:pPr/>
-            <a:r>
-              <a:t>A decision tree works exactly like a flowchart:</a:t>
-            </a:r>
-          </a:p>
-          <a:p>
-            <a:pPr lvl="1"/>
-            <a:r>
-              <a:t>bytes_sent &gt; 10,000?  →  YES  →  duration &lt; 0.1s?  →  ATTACK (exfil)</a:t>
-            </a:r>
-          </a:p>
-          <a:p>
-            <a:pPr lvl="1"/>
-            <a:r>
-              <a:t>unique_dest_ports &gt; 20?  →  YES  →  ATTACK (port scan)</a:t>
-            </a:r>
-          </a:p>
-          <a:p>
-            <a:pPr/>
-            <a:r>
-              <a:t>The model learns which questions to ask and at what thresholds</a:t>
-            </a:r>
-          </a:p>
-          <a:p>
-            <a:pPr lvl="1"/>
-            <a:r>
-              <a:t>It picks the splits that best separate your classes</a:t>
-            </a:r>
-          </a:p>
-          <a:p>
-            <a:pPr/>
-            <a:r>
-              <a:t>No hand-crafted rules — the tree discovers them from data</a:t>
-            </a:r>
-          </a:p>
-          <a:p>
-            <a:pPr/>
-            <a:r>
-              <a:t>You can read the tree and see exactly why each sample was classified</a:t>
-            </a:r>
-          </a:p>
-        </p:txBody>
-      </p:sp>
+              <a:t>Decision Tree — A Flowchart of Learned Yes/No Questions</a:t>
+            </a:r>
+          </a:p>
+        </p:txBody>
+      </p:sp>
+      <p:pic>
+        <p:nvPicPr>
+          <p:cNvPr id="3" name="Picture 2" descr="dt_tree.png"/>
+          <p:cNvPicPr>
+            <a:picLocks noChangeAspect="1"/>
+          </p:cNvPicPr>
+          <p:nvPr/>
+        </p:nvPicPr>
+        <p:blipFill>
+          <a:blip r:embed="rId2"/>
+          <a:stretch>
+            <a:fillRect/>
+          </a:stretch>
+        </p:blipFill>
+        <p:spPr>
+          <a:xfrm>
+            <a:off x="1097280" y="1188720"/>
+            <a:ext cx="10058400" cy="5913539"/>
+          </a:xfrm>
+          <a:prstGeom prst="rect">
+            <a:avLst/>
+          </a:prstGeom>
+        </p:spPr>
+      </p:pic>
     </p:spTree>
   </p:cSld>
   <p:clrMapOvr>
@@ -9246,7 +9340,7 @@
             <a:spLocks noGrp="1"/>
           </p:cNvSpPr>
           <p:nvPr>
-            <p:ph type="body" idx="13" sz="quarter"/>
+            <p:ph type="body" idx="14" sz="quarter"/>
           </p:nvPr>
         </p:nvSpPr>
         <p:spPr/>
@@ -9255,12 +9349,7 @@
           <a:lstStyle/>
           <a:p>
             <a:r>
-              <a:t>Network Traffic</a:t>
-            </a:r>
-          </a:p>
-          <a:p>
-            <a:r>
-              <a:t>Classifier</a:t>
+              <a:t>— Interpretability is a feature</a:t>
             </a:r>
           </a:p>
         </p:txBody>
@@ -9268,6 +9357,58 @@
       <p:sp>
         <p:nvSpPr>
           <p:cNvPr id="3" name="Text Placeholder 2"/>
+          <p:cNvSpPr>
+            <a:spLocks noGrp="1"/>
+          </p:cNvSpPr>
+          <p:nvPr>
+            <p:ph type="body" idx="15" sz="quarter"/>
+          </p:nvPr>
+        </p:nvSpPr>
+        <p:spPr/>
+        <p:txBody>
+          <a:bodyPr/>
+          <a:lstStyle/>
+          <a:p>
+            <a:r>
+              <a:t>The only ML model where you</a:t>
+            </a:r>
+          </a:p>
+          <a:p>
+            <a:r>
+              <a:t>can print the learned rules</a:t>
+            </a:r>
+          </a:p>
+          <a:p>
+            <a:r>
+              <a:t>as a readable flowchart.</a:t>
+            </a:r>
+          </a:p>
+        </p:txBody>
+      </p:sp>
+      <p:sp>
+        <p:nvSpPr>
+          <p:cNvPr id="4" name="Title 3"/>
+          <p:cNvSpPr>
+            <a:spLocks noGrp="1"/>
+          </p:cNvSpPr>
+          <p:nvPr>
+            <p:ph type="title"/>
+          </p:nvPr>
+        </p:nvSpPr>
+        <p:spPr/>
+        <p:txBody>
+          <a:bodyPr/>
+          <a:lstStyle/>
+          <a:p>
+            <a:r>
+              <a:t>What Makes Trees Special</a:t>
+            </a:r>
+          </a:p>
+        </p:txBody>
+      </p:sp>
+      <p:sp>
+        <p:nvSpPr>
+          <p:cNvPr id="5" name="Text Placeholder 4"/>
           <p:cNvSpPr>
             <a:spLocks noGrp="1"/>
           </p:cNvSpPr>
@@ -9280,8 +9421,39 @@
           <a:bodyPr/>
           <a:lstStyle/>
           <a:p>
-            <a:r>
-              <a:t>02</a:t>
+            <a:pPr/>
+            <a:r>
+              <a:t>The model learns which questions to ask</a:t>
+            </a:r>
+          </a:p>
+          <a:p>
+            <a:pPr/>
+            <a:r>
+              <a:t>And at what thresholds to split</a:t>
+            </a:r>
+          </a:p>
+          <a:p>
+            <a:pPr/>
+            <a:r>
+              <a:t>No hand-crafted rules needed</a:t>
+            </a:r>
+          </a:p>
+          <a:p>
+            <a:pPr/>
+            <a:r>
+              <a:t>The tree discovers them from data</a:t>
+            </a:r>
+          </a:p>
+          <a:p>
+            <a:pPr/>
+            <a:r>
+              <a:t>You can read the result and see exactly</a:t>
+            </a:r>
+          </a:p>
+          <a:p>
+            <a:pPr lvl="1"/>
+            <a:r>
+              <a:t>why each sample was classified</a:t>
             </a:r>
           </a:p>
         </p:txBody>
@@ -9306,12 +9478,12 @@
       <p:grpSpPr/>
       <p:sp>
         <p:nvSpPr>
-          <p:cNvPr id="2" name="Title 1"/>
+          <p:cNvPr id="2" name="Text Placeholder 1"/>
           <p:cNvSpPr>
             <a:spLocks noGrp="1"/>
           </p:cNvSpPr>
           <p:nvPr>
-            <p:ph type="title"/>
+            <p:ph type="body" idx="13" sz="quarter"/>
           </p:nvPr>
         </p:nvSpPr>
         <p:spPr/>
@@ -9320,19 +9492,24 @@
           <a:lstStyle/>
           <a:p>
             <a:r>
-              <a:t>Real-Life Example: Network Traffic Classifier</a:t>
-            </a:r>
-          </a:p>
-        </p:txBody>
-      </p:sp>
-      <p:sp>
-        <p:nvSpPr>
-          <p:cNvPr id="3" name="Content Placeholder 2"/>
+              <a:t>How Splits</a:t>
+            </a:r>
+          </a:p>
+          <a:p>
+            <a:r>
+              <a:t>Are Chosen</a:t>
+            </a:r>
+          </a:p>
+        </p:txBody>
+      </p:sp>
+      <p:sp>
+        <p:nvSpPr>
+          <p:cNvPr id="3" name="Text Placeholder 2"/>
           <p:cNvSpPr>
             <a:spLocks noGrp="1"/>
           </p:cNvSpPr>
           <p:nvPr>
-            <p:ph idx="1"/>
+            <p:ph type="body" idx="16" sz="quarter"/>
           </p:nvPr>
         </p:nvSpPr>
         <p:spPr/>
@@ -9340,57 +9517,8 @@
           <a:bodyPr/>
           <a:lstStyle/>
           <a:p>
-            <a:pPr/>
-            <a:r>
-              <a:t>Features from a network connection log:</a:t>
-            </a:r>
-          </a:p>
-          <a:p>
-            <a:pPr lvl="1"/>
-            <a:r>
-              <a:t>duration — how long the connection lasted (seconds)</a:t>
-            </a:r>
-          </a:p>
-          <a:p>
-            <a:pPr lvl="1"/>
-            <a:r>
-              <a:t>bytes_sent — total bytes transferred</a:t>
-            </a:r>
-          </a:p>
-          <a:p>
-            <a:pPr lvl="1"/>
-            <a:r>
-              <a:t>packets_sent — number of packets</a:t>
-            </a:r>
-          </a:p>
-          <a:p>
-            <a:pPr lvl="1"/>
-            <a:r>
-              <a:t>unique_dest_ports — how many different ports were contacted</a:t>
-            </a:r>
-          </a:p>
-          <a:p>
-            <a:pPr lvl="1"/>
-            <a:r>
-              <a:t>connection_rate — connections per minute from this IP</a:t>
-            </a:r>
-          </a:p>
-          <a:p>
-            <a:pPr/>
-            <a:r>
-              <a:t>Attack signatures:</a:t>
-            </a:r>
-          </a:p>
-          <a:p>
-            <a:pPr lvl="1"/>
-            <a:r>
-              <a:t>Port scan: many connections, short duration, many unique ports</a:t>
-            </a:r>
-          </a:p>
-          <a:p>
-            <a:pPr lvl="1"/>
-            <a:r>
-              <a:t>Data exfil: long connection, large bytes_sent, few unique ports</a:t>
+            <a:r>
+              <a:t>02</a:t>
             </a:r>
           </a:p>
         </p:txBody>
@@ -9415,12 +9543,12 @@
       <p:grpSpPr/>
       <p:sp>
         <p:nvSpPr>
-          <p:cNvPr id="2" name="Text Placeholder 1"/>
+          <p:cNvPr id="2" name="Title 1"/>
           <p:cNvSpPr>
             <a:spLocks noGrp="1"/>
           </p:cNvSpPr>
           <p:nvPr>
-            <p:ph type="body" idx="13" sz="quarter"/>
+            <p:ph type="title"/>
           </p:nvPr>
         </p:nvSpPr>
         <p:spPr/>
@@ -9429,37 +9557,35 @@
           <a:lstStyle/>
           <a:p>
             <a:r>
-              <a:t>How Splits</a:t>
-            </a:r>
-          </a:p>
-          <a:p>
-            <a:r>
-              <a:t>Are Chosen</a:t>
-            </a:r>
-          </a:p>
-        </p:txBody>
-      </p:sp>
-      <p:sp>
-        <p:nvSpPr>
-          <p:cNvPr id="3" name="Text Placeholder 2"/>
-          <p:cNvSpPr>
-            <a:spLocks noGrp="1"/>
-          </p:cNvSpPr>
-          <p:nvPr>
-            <p:ph type="body" idx="16" sz="quarter"/>
-          </p:nvPr>
-        </p:nvSpPr>
-        <p:spPr/>
-        <p:txBody>
-          <a:bodyPr/>
-          <a:lstStyle/>
-          <a:p>
-            <a:r>
-              <a:t>03</a:t>
-            </a:r>
-          </a:p>
-        </p:txBody>
-      </p:sp>
+              <a:t>Gini Impurity — Measuring Split Quality</a:t>
+            </a:r>
+          </a:p>
+        </p:txBody>
+      </p:sp>
+      <p:pic>
+        <p:nvPicPr>
+          <p:cNvPr id="3" name="Picture 2" descr="dt_gini.png"/>
+          <p:cNvPicPr>
+            <a:picLocks noChangeAspect="1"/>
+          </p:cNvPicPr>
+          <p:nvPr/>
+        </p:nvPicPr>
+        <p:blipFill>
+          <a:blip r:embed="rId2"/>
+          <a:stretch>
+            <a:fillRect/>
+          </a:stretch>
+        </p:blipFill>
+        <p:spPr>
+          <a:xfrm>
+            <a:off x="1097280" y="1371600"/>
+            <a:ext cx="10058400" cy="3859703"/>
+          </a:xfrm>
+          <a:prstGeom prst="rect">
+            <a:avLst/>
+          </a:prstGeom>
+        </p:spPr>
+      </p:pic>
     </p:spTree>
   </p:cSld>
   <p:clrMapOvr>
@@ -9494,7 +9620,7 @@
           <a:lstStyle/>
           <a:p>
             <a:r>
-              <a:t>How the Tree Chooses Splits</a:t>
+              <a:t>The Splitting Process</a:t>
             </a:r>
           </a:p>
         </p:txBody>
@@ -9522,43 +9648,37 @@
           <a:p>
             <a:pPr/>
             <a:r>
-              <a:t>It picks the split that best separates the classes</a:t>
+              <a:t>It picks the split that reduces impurity the most</a:t>
             </a:r>
           </a:p>
           <a:p>
             <a:pPr/>
             <a:r>
-              <a:t>Measured by Gini impurity (or entropy):</a:t>
-            </a:r>
-          </a:p>
-          <a:p>
-            <a:pPr lvl="1"/>
-            <a:r>
               <a:t>Gini = 0.0 → perfectly pure node (all one class)</a:t>
             </a:r>
           </a:p>
           <a:p>
-            <a:pPr lvl="1"/>
-            <a:r>
-              <a:t>Gini = 0.5 → worst case (50/50 mix)</a:t>
-            </a:r>
-          </a:p>
-          <a:p>
             <a:pPr/>
             <a:r>
-              <a:t>The tree greedily picks the split that reduces impurity the most</a:t>
-            </a:r>
-          </a:p>
-          <a:p>
-            <a:pPr lvl="1"/>
-            <a:r>
-              <a:t>This is called information gain</a:t>
+              <a:t>Gini = 0.5 → worst case (50/50 mix, no information)</a:t>
             </a:r>
           </a:p>
           <a:p>
             <a:pPr/>
             <a:r>
+              <a:t>The tree greedily picks the best split — this is called information gain</a:t>
+            </a:r>
+          </a:p>
+          <a:p>
+            <a:pPr/>
+            <a:r>
               <a:t>Result: an automatically learned set of if/else rules</a:t>
+            </a:r>
+          </a:p>
+          <a:p>
+            <a:pPr/>
+            <a:r>
+              <a:t>No maths needed from you — sklearn handles it all</a:t>
             </a:r>
           </a:p>
         </p:txBody>
@@ -9583,12 +9703,12 @@
       <p:grpSpPr/>
       <p:sp>
         <p:nvSpPr>
-          <p:cNvPr id="2" name="Title 1"/>
+          <p:cNvPr id="2" name="Text Placeholder 1"/>
           <p:cNvSpPr>
             <a:spLocks noGrp="1"/>
           </p:cNvSpPr>
           <p:nvPr>
-            <p:ph type="title"/>
+            <p:ph type="body" idx="13" sz="quarter"/>
           </p:nvPr>
         </p:nvSpPr>
         <p:spPr/>
@@ -9597,19 +9717,24 @@
           <a:lstStyle/>
           <a:p>
             <a:r>
-              <a:t>Feature Importance</a:t>
-            </a:r>
-          </a:p>
-        </p:txBody>
-      </p:sp>
-      <p:sp>
-        <p:nvSpPr>
-          <p:cNvPr id="3" name="Content Placeholder 2"/>
+              <a:t>Network Traffic</a:t>
+            </a:r>
+          </a:p>
+          <a:p>
+            <a:r>
+              <a:t>Classifier</a:t>
+            </a:r>
+          </a:p>
+        </p:txBody>
+      </p:sp>
+      <p:sp>
+        <p:nvSpPr>
+          <p:cNvPr id="3" name="Text Placeholder 2"/>
           <p:cNvSpPr>
             <a:spLocks noGrp="1"/>
           </p:cNvSpPr>
           <p:nvPr>
-            <p:ph idx="1"/>
+            <p:ph type="body" idx="16" sz="quarter"/>
           </p:nvPr>
         </p:nvSpPr>
         <p:spPr/>
@@ -9617,57 +9742,8 @@
           <a:bodyPr/>
           <a:lstStyle/>
           <a:p>
-            <a:pPr/>
-            <a:r>
-              <a:t>model.feature_importances_ tells you which features the tree relies on</a:t>
-            </a:r>
-          </a:p>
-          <a:p>
-            <a:pPr/>
-            <a:r>
-              <a:t>Higher importance = feature was used in more splits with higher impact</a:t>
-            </a:r>
-          </a:p>
-          <a:p>
-            <a:pPr/>
-            <a:r>
-              <a:t>Example output:</a:t>
-            </a:r>
-          </a:p>
-          <a:p>
-            <a:pPr lvl="1"/>
-            <a:r>
-              <a:t>bytes_sent:         0.42</a:t>
-            </a:r>
-          </a:p>
-          <a:p>
-            <a:pPr lvl="1"/>
-            <a:r>
-              <a:t>unique_dest_ports:  0.31</a:t>
-            </a:r>
-          </a:p>
-          <a:p>
-            <a:pPr lvl="1"/>
-            <a:r>
-              <a:t>duration:           0.18</a:t>
-            </a:r>
-          </a:p>
-          <a:p>
-            <a:pPr lvl="1"/>
-            <a:r>
-              <a:t>connection_rate:    0.09</a:t>
-            </a:r>
-          </a:p>
-          <a:p>
-            <a:pPr/>
-            <a:r>
-              <a:t>Great for understanding why your model works</a:t>
-            </a:r>
-          </a:p>
-          <a:p>
-            <a:pPr/>
-            <a:r>
-              <a:t>And for identifying which log fields to prioritise in collection</a:t>
+            <a:r>
+              <a:t>03</a:t>
             </a:r>
           </a:p>
         </p:txBody>

</xml_diff>